<commit_message>
Move Defender for Identity to defense in depth, and analytics rules and threat intelligence to foundational
DR.11 and DR.4 need Defender for Identity licensing and a sensor on each
domain controller from the client, so they are defense in depth and share
the mdi item in Later with its licensing ask. DR.9 and DR.7 are switched on
at build, so they are foundational and a gap goes first in Now. The detect
roadmap item keeps only vulnerability assessment, as vulnassess. With no
foundational control needing a license, the licensed path is removed.
The baseline document and the regenerated controls standard follow.

Co-Authored-By: Claude Opus 5.5 <noreply@anthropic.com>
Claude-Session: https://claude.ai/code/session_01BwGgRXsZ3dQSsmTGKk5FJw
</commit_message>
<xml_diff>
--- a/docs/The Controls That Matter.pptx
+++ b/docs/The Controls That Matter.pptx
@@ -121,7 +121,7 @@
   <p:extLst>
     <p:ext uri="{521415D9-36F7-43E2-AB2F-B90AF26B5E84}">
       <p14:sectionLst xmlns:p14="http://schemas.microsoft.com/office/powerpoint/2010/main">
-        <p14:section name="Overview" id="{f03fb022-9087-d1fb-c5a1-f419678fbd7c}">
+        <p14:section name="Overview" id="{d9f0ad6d-f075-ff64-e781-d49d342b543e}">
           <p14:sldIdLst>
             <p14:sldId id="256"/>
             <p14:sldId id="257"/>
@@ -129,37 +129,37 @@
             <p14:sldId id="259"/>
           </p14:sldIdLst>
         </p14:section>
-        <p14:section name="Identity and access" id="{f97e0c09-3556-b4cf-2767-8ffec2aa440f}">
+        <p14:section name="Identity and access" id="{011da6e0-c1c1-a106-03b2-40566a47a735}">
           <p14:sldIdLst>
             <p14:sldId id="260"/>
             <p14:sldId id="261"/>
           </p14:sldIdLst>
         </p14:section>
-        <p14:section name="Endpoint and workload" id="{7e14017d-bc95-b596-7d49-051fa7382eb5}">
+        <p14:section name="Endpoint and workload" id="{4a029186-0a55-aed6-74df-f47d14242e4a}">
           <p14:sldIdLst>
             <p14:sldId id="262"/>
             <p14:sldId id="263"/>
           </p14:sldIdLst>
         </p14:section>
-        <p14:section name="Network and boundary" id="{b5a24a79-284e-aa39-f36e-3566c6199faa}">
+        <p14:section name="Network and boundary" id="{186d929f-8c49-5a25-c8aa-bad834a6cd31}">
           <p14:sldIdLst>
             <p14:sldId id="264"/>
             <p14:sldId id="265"/>
           </p14:sldIdLst>
         </p14:section>
-        <p14:section name="Data protection" id="{c7b46240-fbf0-d845-4a72-5351092d04b5}">
+        <p14:section name="Data protection" id="{cc1a25bf-b2d0-dd11-beba-d24ae51b6d4a}">
           <p14:sldIdLst>
             <p14:sldId id="266"/>
             <p14:sldId id="267"/>
           </p14:sldIdLst>
         </p14:section>
-        <p14:section name="Detection and response" id="{b1197866-a201-d873-ab55-7974f41c0d38}">
+        <p14:section name="Detection and response" id="{f04bdd99-17f9-da7e-d99d-105a81d68e19}">
           <p14:sldIdLst>
             <p14:sldId id="268"/>
             <p14:sldId id="269"/>
           </p14:sldIdLst>
         </p14:section>
-        <p14:section name="Feedback" id="{c06557e6-8ea5-9f41-48df-4619bee4bc5e}">
+        <p14:section name="Feedback" id="{920fdea2-7ba2-f8e0-f4d5-7f0a94820d08}">
           <p14:sldIdLst>
             <p14:sldId id="270"/>
           </p14:sldIdLst>
@@ -1277,7 +1277,7 @@
           <a:p>
             <a:r>
               <a:rPr lang="en-US" dirty="0"/>
-              <a:t>Detection and response, foundational controls. These are configured when the environment is built and are expected at E at every review. Endpoint sensors active on onboarded Azure virtual machines: Active sensors among the Azure virtual machines onboarded to Defender for Endpoint, seen in the last 7 days. Workstations and network devices such as firewalls are not part of this measure. Cloud workload protection across the resource estate: Eligible resources on a Standard Defender for Cloud plan. Subscription plan configuration, estimated. Domain controller telemetry collected continuously: Domain controller security events arriving in the workspace. Alerts closed with a documented disposition: Alerts closed in the last 30 days that carry a classification and a closing comment. Defender for Identity sensors healthy on domain controllers: Sensors reporting healthy, of sensors registered. Audit logging initiative compliant across its resources: Resources compliant with the ATMO-MXDR diagnostic logging initiative.</a:t>
+              <a:t>Detection and response, foundational controls. These are configured when the environment is built and are expected at E at every review. Endpoint sensors active on onboarded Azure virtual machines: Active sensors among the Azure virtual machines onboarded to Defender for Endpoint, seen in the last 7 days. Workstations and network devices such as firewalls are not part of this measure. Cloud workload protection across the resource estate: Eligible resources on a Standard Defender for Cloud plan, read from the subscription plan configuration. Analytics rules enabled in Sentinel: Enabled analytics rules across all workspaces. Threat intelligence indicators ingested tenant-wide: Threat intelligence indicators available for matching in the workspace. Alerts closed with a documented disposition: Alerts closed in the last 30 days that carry a classification and a closing comment. Audit logging initiative compliant across its resources: Resources compliant with the ATMO-MXDR diagnostic logging initiative.</a:t>
             </a:r>
             <a:endParaRPr lang="en-US" dirty="0"/>
           </a:p>
@@ -1365,7 +1365,7 @@
           <a:p>
             <a:r>
               <a:rPr lang="en-US" dirty="0"/>
-              <a:t>Detection and response, defense in depth controls. Each of these waits on something the client approves, schedules or licenses, and is sequenced on the roadmap. Analytics rules enabled in Sentinel: Enabled analytics rules across all workspaces. Threat intelligence indicators ingested tenant-wide: Threat intelligence indicators available for matching in the workspace. Diagnostic logging enabled on all platform resources: Resources with every diagnostic and audit logging assessment healthy.</a:t>
+              <a:t>Detection and response, defense in depth controls. Each of these waits on something the client approves, schedules or licenses, and is sequenced on the roadmap. Domain controller telemetry collected continuously: Domain controller security events arriving in the workspace. Defender for Identity sensors healthy on domain controllers: Sensors reporting healthy, of sensors registered. Diagnostic logging enabled on all platform resources: Resources with every diagnostic and audit logging assessment healthy.</a:t>
             </a:r>
             <a:endParaRPr lang="en-US" dirty="0"/>
           </a:p>
@@ -3424,7 +3424,7 @@
                   <a:schemeClr val="accent1"/>
                 </a:solidFill>
               </a:rPr>
-              <a:t>Version Oct 12, 2026 · 31 foundational and 22 defense in depth controls across five pillars</a:t>
+              <a:t>Version Oct 16, 2026 · 31 foundational and 22 defense in depth controls across five pillars</a:t>
             </a:r>
             <a:endParaRPr lang="en-US" sz="1400" dirty="0"/>
           </a:p>
@@ -6228,7 +6228,7 @@
                   <a:schemeClr val="accent6"/>
                 </a:solidFill>
               </a:rPr>
-              <a:t>Eligible resources on a Standard Defender for Cloud plan. Subscription plan configuration, estimated.</a:t>
+              <a:t>Eligible resources on a Standard Defender for Cloud plan, read from the subscription plan configuration.</a:t>
             </a:r>
             <a:endParaRPr lang="en-US" sz="1400" dirty="0"/>
           </a:p>
@@ -6303,7 +6303,7 @@
       </p:sp>
       <p:sp>
         <p:nvSpPr>
-          <p:cNvPr id="12" name="F3 Domain controller telemetry collected continuously"/>
+          <p:cNvPr id="12" name="F3 Analytics rules enabled in Sentinel"/>
           <p:cNvSpPr txBox="1"/>
           <p:nvPr/>
         </p:nvSpPr>
@@ -6331,7 +6331,7 @@
                   <a:schemeClr val="tx2"/>
                 </a:solidFill>
               </a:rPr>
-              <a:t>Domain controller telemetry collected continuously</a:t>
+              <a:t>Analytics rules enabled in Sentinel</a:t>
             </a:r>
             <a:endParaRPr lang="en-US" sz="1400" dirty="0"/>
           </a:p>
@@ -6348,7 +6348,7 @@
                   <a:schemeClr val="accent6"/>
                 </a:solidFill>
               </a:rPr>
-              <a:t>Domain controller security events arriving in the workspace.</a:t>
+              <a:t>Enabled analytics rules across all workspaces.</a:t>
             </a:r>
             <a:endParaRPr lang="en-US" sz="1400" dirty="0"/>
           </a:p>
@@ -6423,7 +6423,7 @@
       </p:sp>
       <p:sp>
         <p:nvSpPr>
-          <p:cNvPr id="15" name="F4 Alerts closed with a documented disposition"/>
+          <p:cNvPr id="15" name="F4 Threat intelligence indicators ingested tenant-wide"/>
           <p:cNvSpPr txBox="1"/>
           <p:nvPr/>
         </p:nvSpPr>
@@ -6451,7 +6451,7 @@
                   <a:schemeClr val="tx2"/>
                 </a:solidFill>
               </a:rPr>
-              <a:t>Alerts closed with a documented disposition</a:t>
+              <a:t>Threat intelligence indicators ingested tenant-wide</a:t>
             </a:r>
             <a:endParaRPr lang="en-US" sz="1400" dirty="0"/>
           </a:p>
@@ -6468,7 +6468,7 @@
                   <a:schemeClr val="accent6"/>
                 </a:solidFill>
               </a:rPr>
-              <a:t>Alerts closed in the last 30 days that carry a classification and a closing comment.</a:t>
+              <a:t>Threat intelligence indicators available for matching in the workspace.</a:t>
             </a:r>
             <a:endParaRPr lang="en-US" sz="1400" dirty="0"/>
           </a:p>
@@ -6543,7 +6543,7 @@
       </p:sp>
       <p:sp>
         <p:nvSpPr>
-          <p:cNvPr id="18" name="F5 Defender for Identity sensors healthy on domain controllers"/>
+          <p:cNvPr id="18" name="F5 Alerts closed with a documented disposition"/>
           <p:cNvSpPr txBox="1"/>
           <p:nvPr/>
         </p:nvSpPr>
@@ -6571,7 +6571,7 @@
                   <a:schemeClr val="tx2"/>
                 </a:solidFill>
               </a:rPr>
-              <a:t>Defender for Identity sensors healthy on domain controllers</a:t>
+              <a:t>Alerts closed with a documented disposition</a:t>
             </a:r>
             <a:endParaRPr lang="en-US" sz="1400" dirty="0"/>
           </a:p>
@@ -6588,7 +6588,7 @@
                   <a:schemeClr val="accent6"/>
                 </a:solidFill>
               </a:rPr>
-              <a:t>Sensors reporting healthy, of sensors registered.</a:t>
+              <a:t>Alerts closed in the last 30 days that carry a classification and a closing comment.</a:t>
             </a:r>
             <a:endParaRPr lang="en-US" sz="1400" dirty="0"/>
           </a:p>
@@ -6824,11 +6824,11 @@
         <p:spPr>
           <a:xfrm>
             <a:off x="548640" y="1600200"/>
-            <a:ext cx="3515258" cy="1677924"/>
+            <a:ext cx="3515258" cy="1495044"/>
           </a:xfrm>
           <a:prstGeom prst="roundRect">
             <a:avLst>
-              <a:gd name="adj" fmla="val 4360"/>
+              <a:gd name="adj" fmla="val 4893"/>
             </a:avLst>
           </a:prstGeom>
           <a:solidFill>
@@ -6884,14 +6884,14 @@
       </p:sp>
       <p:sp>
         <p:nvSpPr>
-          <p:cNvPr id="6" name="D1 Analytics rules enabled in Sentinel"/>
+          <p:cNvPr id="6" name="D1 Domain controller telemetry collected continuously"/>
           <p:cNvSpPr txBox="1"/>
           <p:nvPr/>
         </p:nvSpPr>
         <p:spPr>
           <a:xfrm>
             <a:off x="1371600" y="1783080"/>
-            <a:ext cx="2527706" cy="1385316"/>
+            <a:ext cx="2527706" cy="1202436"/>
           </a:xfrm>
           <a:prstGeom prst="rect">
             <a:avLst/>
@@ -6912,7 +6912,7 @@
                   <a:schemeClr val="tx2"/>
                 </a:solidFill>
               </a:rPr>
-              <a:t>Analytics rules enabled in Sentinel</a:t>
+              <a:t>Domain controller telemetry collected continuously</a:t>
             </a:r>
             <a:endParaRPr lang="en-US" sz="1400" dirty="0"/>
           </a:p>
@@ -6929,7 +6929,7 @@
                   <a:schemeClr val="accent6"/>
                 </a:solidFill>
               </a:rPr>
-              <a:t>Enabled analytics rules across all workspaces.</a:t>
+              <a:t>Domain controller security events arriving in the workspace.</a:t>
             </a:r>
             <a:endParaRPr lang="en-US" sz="1400" dirty="0"/>
           </a:p>
@@ -6944,11 +6944,11 @@
         <p:spPr>
           <a:xfrm>
             <a:off x="4338218" y="1600200"/>
-            <a:ext cx="3515258" cy="1677924"/>
+            <a:ext cx="3515258" cy="1495044"/>
           </a:xfrm>
           <a:prstGeom prst="roundRect">
             <a:avLst>
-              <a:gd name="adj" fmla="val 4360"/>
+              <a:gd name="adj" fmla="val 4893"/>
             </a:avLst>
           </a:prstGeom>
           <a:solidFill>
@@ -7004,14 +7004,14 @@
       </p:sp>
       <p:sp>
         <p:nvSpPr>
-          <p:cNvPr id="9" name="D2 Threat intelligence indicators ingested tenant-wide"/>
+          <p:cNvPr id="9" name="D2 Defender for Identity sensors healthy on domain controllers"/>
           <p:cNvSpPr txBox="1"/>
           <p:nvPr/>
         </p:nvSpPr>
         <p:spPr>
           <a:xfrm>
             <a:off x="5161178" y="1783080"/>
-            <a:ext cx="2527706" cy="1385316"/>
+            <a:ext cx="2527706" cy="1202436"/>
           </a:xfrm>
           <a:prstGeom prst="rect">
             <a:avLst/>
@@ -7032,7 +7032,7 @@
                   <a:schemeClr val="tx2"/>
                 </a:solidFill>
               </a:rPr>
-              <a:t>Threat intelligence indicators ingested tenant-wide</a:t>
+              <a:t>Defender for Identity sensors healthy on domain controllers</a:t>
             </a:r>
             <a:endParaRPr lang="en-US" sz="1400" dirty="0"/>
           </a:p>
@@ -7049,7 +7049,7 @@
                   <a:schemeClr val="accent6"/>
                 </a:solidFill>
               </a:rPr>
-              <a:t>Threat intelligence indicators available for matching in the workspace.</a:t>
+              <a:t>Sensors reporting healthy, of sensors registered.</a:t>
             </a:r>
             <a:endParaRPr lang="en-US" sz="1400" dirty="0"/>
           </a:p>
@@ -7064,11 +7064,11 @@
         <p:spPr>
           <a:xfrm>
             <a:off x="8127797" y="1600200"/>
-            <a:ext cx="3515258" cy="1677924"/>
+            <a:ext cx="3515258" cy="1495044"/>
           </a:xfrm>
           <a:prstGeom prst="roundRect">
             <a:avLst>
-              <a:gd name="adj" fmla="val 4360"/>
+              <a:gd name="adj" fmla="val 4893"/>
             </a:avLst>
           </a:prstGeom>
           <a:solidFill>
@@ -7131,7 +7131,7 @@
         <p:spPr>
           <a:xfrm>
             <a:off x="8950757" y="1783080"/>
-            <a:ext cx="2527706" cy="1385316"/>
+            <a:ext cx="2527706" cy="1202436"/>
           </a:xfrm>
           <a:prstGeom prst="rect">
             <a:avLst/>

</xml_diff>

<commit_message>
Grade analytics rules as an enabled rule in every Sentinel workspace
The owner confirmed Atmosera's rules carry no naming convention, so the
evidence cannot identify the standard set. DR.9 now reads In force only
when every workspace in scope has an enabled rule, from a complete read.
A workspace read with none is Not in force, and a partial read stays
ungathered. The enabled of total count is context in the note, so
disabled rules never create a foundational gap. Every surface carries
the new name and measure.

Co-Authored-By: Claude Opus 5.5 <noreply@anthropic.com>
Claude-Session: https://claude.ai/code/session_01BwGgRXsZ3dQSsmTGKk5FJw
</commit_message>
<xml_diff>
--- a/docs/The Controls That Matter.pptx
+++ b/docs/The Controls That Matter.pptx
@@ -121,7 +121,7 @@
   <p:extLst>
     <p:ext uri="{521415D9-36F7-43E2-AB2F-B90AF26B5E84}">
       <p14:sectionLst xmlns:p14="http://schemas.microsoft.com/office/powerpoint/2010/main">
-        <p14:section name="Overview" id="{d9f0ad6d-f075-ff64-e781-d49d342b543e}">
+        <p14:section name="Overview" id="{18faf753-0458-c8d1-6c50-b58d0617b7ae}">
           <p14:sldIdLst>
             <p14:sldId id="256"/>
             <p14:sldId id="257"/>
@@ -129,37 +129,37 @@
             <p14:sldId id="259"/>
           </p14:sldIdLst>
         </p14:section>
-        <p14:section name="Identity and access" id="{011da6e0-c1c1-a106-03b2-40566a47a735}">
+        <p14:section name="Identity and access" id="{091d7165-baea-b30c-f64d-57b25e00ed7e}">
           <p14:sldIdLst>
             <p14:sldId id="260"/>
             <p14:sldId id="261"/>
           </p14:sldIdLst>
         </p14:section>
-        <p14:section name="Endpoint and workload" id="{4a029186-0a55-aed6-74df-f47d14242e4a}">
+        <p14:section name="Endpoint and workload" id="{e52e23fc-abf6-5549-588a-7eba83b619bb}">
           <p14:sldIdLst>
             <p14:sldId id="262"/>
             <p14:sldId id="263"/>
           </p14:sldIdLst>
         </p14:section>
-        <p14:section name="Network and boundary" id="{186d929f-8c49-5a25-c8aa-bad834a6cd31}">
+        <p14:section name="Network and boundary" id="{d64a4dce-c561-9b60-402a-13cab30c4d77}">
           <p14:sldIdLst>
             <p14:sldId id="264"/>
             <p14:sldId id="265"/>
           </p14:sldIdLst>
         </p14:section>
-        <p14:section name="Data protection" id="{cc1a25bf-b2d0-dd11-beba-d24ae51b6d4a}">
+        <p14:section name="Data protection" id="{a4219d7c-cb6e-a31e-f193-41dd971c57a9}">
           <p14:sldIdLst>
             <p14:sldId id="266"/>
             <p14:sldId id="267"/>
           </p14:sldIdLst>
         </p14:section>
-        <p14:section name="Detection and response" id="{f04bdd99-17f9-da7e-d99d-105a81d68e19}">
+        <p14:section name="Detection and response" id="{cdcd07e4-3b3d-594c-4156-5a36456213d7}">
           <p14:sldIdLst>
             <p14:sldId id="268"/>
             <p14:sldId id="269"/>
           </p14:sldIdLst>
         </p14:section>
-        <p14:section name="Feedback" id="{920fdea2-7ba2-f8e0-f4d5-7f0a94820d08}">
+        <p14:section name="Feedback" id="{2743ca00-a922-8971-9699-bb3feba909e2}">
           <p14:sldIdLst>
             <p14:sldId id="270"/>
           </p14:sldIdLst>
@@ -1277,7 +1277,7 @@
           <a:p>
             <a:r>
               <a:rPr lang="en-US" dirty="0"/>
-              <a:t>Detection and response, foundational controls. These are configured when the environment is built and are expected at E at every review. Endpoint sensors active on onboarded Azure virtual machines: Active sensors among the Azure virtual machines onboarded to Defender for Endpoint, seen in the last 7 days. Workstations and network devices such as firewalls are not part of this measure. Cloud workload protection across the resource estate: Eligible resources on a Standard Defender for Cloud plan, read from the subscription plan configuration. Analytics rules enabled in Sentinel: Enabled analytics rules across all workspaces. Threat intelligence indicators ingested tenant-wide: Threat intelligence indicators available for matching in the workspace. Alerts closed with a documented disposition: Alerts closed in the last 30 days that carry a classification and a closing comment. Audit logging initiative compliant across its resources: Resources compliant with the ATMO-MXDR diagnostic logging initiative.</a:t>
+              <a:t>Detection and response, foundational controls. These are configured when the environment is built and are expected at E at every review. Endpoint sensors active on onboarded Azure virtual machines: Active sensors among the Azure virtual machines onboarded to Defender for Endpoint, seen in the last 7 days. Workstations and network devices such as firewalls are not part of this measure. Cloud workload protection across the resource estate: Eligible resources on a Standard Defender for Cloud plan, read from the subscription plan configuration. Analytics rules enabled in every Sentinel workspace: Sentinel workspaces with at least one enabled analytics rule, of the workspaces in scope. It does not identify which rules are Atmosera's standard set. Threat intelligence indicators ingested tenant-wide: Threat intelligence indicators available for matching in the workspace. Alerts closed with a documented disposition: Alerts closed in the last 30 days that carry a classification and a closing comment. Audit logging initiative compliant across its resources: Resources compliant with the ATMO-MXDR diagnostic logging initiative.</a:t>
             </a:r>
             <a:endParaRPr lang="en-US" dirty="0"/>
           </a:p>
@@ -6303,7 +6303,7 @@
       </p:sp>
       <p:sp>
         <p:nvSpPr>
-          <p:cNvPr id="12" name="F3 Analytics rules enabled in Sentinel"/>
+          <p:cNvPr id="12" name="F3 Analytics rules enabled in every Sentinel workspace"/>
           <p:cNvSpPr txBox="1"/>
           <p:nvPr/>
         </p:nvSpPr>
@@ -6331,7 +6331,7 @@
                   <a:schemeClr val="tx2"/>
                 </a:solidFill>
               </a:rPr>
-              <a:t>Analytics rules enabled in Sentinel</a:t>
+              <a:t>Analytics rules enabled in every Sentinel workspace</a:t>
             </a:r>
             <a:endParaRPr lang="en-US" sz="1400" dirty="0"/>
           </a:p>
@@ -6348,7 +6348,7 @@
                   <a:schemeClr val="accent6"/>
                 </a:solidFill>
               </a:rPr>
-              <a:t>Enabled analytics rules across all workspaces.</a:t>
+              <a:t>Sentinel workspaces with at least one enabled analytics rule, of the workspaces in scope. It does not identify which rules are Atmosera's standard set.</a:t>
             </a:r>
             <a:endParaRPr lang="en-US" sz="1400" dirty="0"/>
           </a:p>

</xml_diff>

<commit_message>
Word configuration-presence controls as the configuration they read
NB.1 reads a network security group or firewall route configured, not
segmentation achieved. DR.2 names its plan-level estimate in the label,
note, pillar narrative and headline, so the deck carries it too. Safe
Links and Safe Attachments say a policy is configured or set, and the
notes say the recipients, exceptions and rule state are not read. DP.3
keeps its row with a note that platform-managed encryption is the Azure
default, and is no longer a fallback data protection win. The controls
standard is regenerated (it also catches up with earlier model changes).

Part of #26. Safe Links and Safe Attachments scope collection: #62.

Co-Authored-By: Claude Opus 5.5 <noreply@anthropic.com>
Claude-Session: https://claude.ai/code/session_01G7sqHHZgrkqDvVG64pLwvx
</commit_message>
<xml_diff>
--- a/docs/The Controls That Matter.pptx
+++ b/docs/The Controls That Matter.pptx
@@ -121,7 +121,7 @@
   <p:extLst>
     <p:ext uri="{521415D9-36F7-43E2-AB2F-B90AF26B5E84}">
       <p14:sectionLst xmlns:p14="http://schemas.microsoft.com/office/powerpoint/2010/main">
-        <p14:section name="Overview" id="{18faf753-0458-c8d1-6c50-b58d0617b7ae}">
+        <p14:section name="Overview" id="{31478f99-389b-eb79-72af-7347030f6c2e}">
           <p14:sldIdLst>
             <p14:sldId id="256"/>
             <p14:sldId id="257"/>
@@ -129,37 +129,37 @@
             <p14:sldId id="259"/>
           </p14:sldIdLst>
         </p14:section>
-        <p14:section name="Identity and access" id="{091d7165-baea-b30c-f64d-57b25e00ed7e}">
+        <p14:section name="Identity and access" id="{359860de-30f9-99a3-eb67-4a2585a45746}">
           <p14:sldIdLst>
             <p14:sldId id="260"/>
             <p14:sldId id="261"/>
           </p14:sldIdLst>
         </p14:section>
-        <p14:section name="Endpoint and workload" id="{e52e23fc-abf6-5549-588a-7eba83b619bb}">
+        <p14:section name="Endpoint and workload" id="{bc59fcf3-2dcd-42b3-afdc-24ab344257a2}">
           <p14:sldIdLst>
             <p14:sldId id="262"/>
             <p14:sldId id="263"/>
           </p14:sldIdLst>
         </p14:section>
-        <p14:section name="Network and boundary" id="{d64a4dce-c561-9b60-402a-13cab30c4d77}">
+        <p14:section name="Network and boundary" id="{7db857fc-a341-eb07-2b28-d7e8edadbabc}">
           <p14:sldIdLst>
             <p14:sldId id="264"/>
             <p14:sldId id="265"/>
           </p14:sldIdLst>
         </p14:section>
-        <p14:section name="Data protection" id="{a4219d7c-cb6e-a31e-f193-41dd971c57a9}">
+        <p14:section name="Data protection" id="{8d75dd8e-404f-1b5d-bfc3-17b1ee3bceff}">
           <p14:sldIdLst>
             <p14:sldId id="266"/>
             <p14:sldId id="267"/>
           </p14:sldIdLst>
         </p14:section>
-        <p14:section name="Detection and response" id="{cdcd07e4-3b3d-594c-4156-5a36456213d7}">
+        <p14:section name="Detection and response" id="{0a3fcf14-c01c-13b1-c1e5-a53c60077814}">
           <p14:sldIdLst>
             <p14:sldId id="268"/>
             <p14:sldId id="269"/>
           </p14:sldIdLst>
         </p14:section>
-        <p14:section name="Feedback" id="{2743ca00-a922-8971-9699-bb3feba909e2}">
+        <p14:section name="Feedback" id="{1e5eb518-a4bd-02c0-ee3e-57e242cd3c0d}">
           <p14:sldIdLst>
             <p14:sldId id="270"/>
           </p14:sldIdLst>
@@ -1013,7 +1013,7 @@
           <a:p>
             <a:r>
               <a:rPr lang="en-US" dirty="0"/>
-              <a:t>Network and boundary, defense in depth controls. Each of these waits on something the client approves, schedules or licenses, and is sequenced on the roadmap. Workload subnets protected by segmentation: Workload subnets with a network security group or a route through the firewall. Storage accounts closed to public networks: Storage accounts with public network access disabled. Blob containers closed to anonymous access: Blob containers set to private at the container level, read in every storage account, so they stay closed even if the account-level setting is relaxed. Directory traffic signed and channel-bound: Domain controllers in Azure requiring LDAP server signing and channel binding. NTLMv2 enforced with LM and NTLM refused: Onboarded Windows virtual machines in Azure sending NTLMv2 responses only.</a:t>
+              <a:t>Network and boundary, defense in depth controls. Each of these waits on something the client approves, schedules or licenses, and is sequenced on the roadmap. Workload subnets with a network security group or firewall route: Workload subnets with a network security group or a route through the firewall configured. The rules and the traffic they permit are not evaluated. Storage accounts closed to public networks: Storage accounts with public network access disabled. Blob containers closed to anonymous access: Blob containers set to private at the container level, read in every storage account, so they stay closed even if the account-level setting is relaxed. Directory traffic signed and channel-bound: Domain controllers in Azure requiring LDAP server signing and channel binding. NTLMv2 enforced with LM and NTLM refused: Onboarded Windows virtual machines in Azure sending NTLMv2 responses only.</a:t>
             </a:r>
             <a:endParaRPr lang="en-US" dirty="0"/>
           </a:p>
@@ -1101,7 +1101,7 @@
           <a:p>
             <a:r>
               <a:rPr lang="en-US" dirty="0"/>
-              <a:t>Data protection, foundational controls. These are configured when the environment is built and are expected at E at every review. Secure transfer required on storage accounts: Storage accounts configured to require secure transfer. Storage minimum TLS 1.2: Storage accounts requiring TLS 1.2 or newer. Key Vault soft delete: Vaults able to recover deleted secrets, keys and certificates. Key Vault purge protection: Vaults protected against permanent deletion during the retention period. Managed disks encrypted at rest: Managed disks encrypted with platform or customer managed keys. Safe Links scanning on mail, Teams and Office: At least one Safe Links policy covers mail, Teams and Office. Safe Attachments blocking malicious files: At least one enabled Safe Attachments policy blocks or replaces malicious attachments. Malicious mail removed after delivery: Post-delivery removals of malicious mail in the last 30 days. Zero-hour auto purge enabled for malware, spam and phishing: Every malware and content filter policy keeps zero-hour auto purge on.</a:t>
+              <a:t>Data protection, foundational controls. These are configured when the environment is built and are expected at E at every review. Secure transfer required on storage accounts: Storage accounts configured to require secure transfer. Storage minimum TLS 1.2: Storage accounts requiring TLS 1.2 or newer. Key Vault soft delete: Vaults able to recover deleted secrets, keys and certificates. Key Vault purge protection: Vaults protected against permanent deletion during the retention period. Managed disks encrypted at rest: Managed disks encrypted with platform or customer managed keys. Platform-managed encryption is on by default in Azure, so this reads the default. Encryption at host is graded separately. Safe Links policy configured for mail, Teams and Office: At least one Safe Links policy has Safe Links on for mail, Teams and Office. The recipients it applies to, its exceptions and its rule state are not read. Safe Attachments policy set to block or replace malicious files: At least one enabled Safe Attachments policy is set to block or replace malicious attachments. The recipients it applies to and its exceptions are not read. Malicious mail removed after delivery: Post-delivery removals of malicious mail in the last 30 days. Zero-hour auto purge enabled for malware, spam and phishing: Every malware and content filter policy keeps zero-hour auto purge on.</a:t>
             </a:r>
             <a:endParaRPr lang="en-US" dirty="0"/>
           </a:p>
@@ -1277,7 +1277,7 @@
           <a:p>
             <a:r>
               <a:rPr lang="en-US" dirty="0"/>
-              <a:t>Detection and response, foundational controls. These are configured when the environment is built and are expected at E at every review. Endpoint sensors active on onboarded Azure virtual machines: Active sensors among the Azure virtual machines onboarded to Defender for Endpoint, seen in the last 7 days. Workstations and network devices such as firewalls are not part of this measure. Cloud workload protection across the resource estate: Eligible resources on a Standard Defender for Cloud plan, read from the subscription plan configuration. Analytics rules enabled in every Sentinel workspace: Sentinel workspaces with at least one enabled analytics rule, of the workspaces in scope. It does not identify which rules are Atmosera's standard set. Threat intelligence indicators ingested tenant-wide: Threat intelligence indicators available for matching in the workspace. Alerts closed with a documented disposition: Alerts closed in the last 30 days that carry a classification and a closing comment. Audit logging initiative compliant across its resources: Resources compliant with the ATMO-MXDR diagnostic logging initiative.</a:t>
+              <a:t>Detection and response, foundational controls. These are configured when the environment is built and are expected at E at every review. Endpoint sensors active on onboarded Azure virtual machines: Active sensors among the Azure virtual machines onboarded to Defender for Endpoint, seen in the last 7 days. Workstations and network devices such as firewalls are not part of this measure. Cloud workload protection plan coverage, a plan-level estimate: Eligible resources on a Standard Defender for Cloud plan, a plan-level estimate read from the subscription plan configuration. Analytics rules enabled in every Sentinel workspace: Sentinel workspaces with at least one enabled analytics rule, of the workspaces in scope. It does not identify which rules are Atmosera's standard set. Threat intelligence indicators ingested tenant-wide: Threat intelligence indicators available for matching in the workspace. Alerts closed with a documented disposition: Alerts closed in the last 30 days that carry a classification and a closing comment. Audit logging initiative compliant across its resources: Resources compliant with the ATMO-MXDR diagnostic logging initiative.</a:t>
             </a:r>
             <a:endParaRPr lang="en-US" dirty="0"/>
           </a:p>
@@ -3540,11 +3540,11 @@
         <p:spPr>
           <a:xfrm>
             <a:off x="548640" y="1600200"/>
-            <a:ext cx="3515258" cy="1819656"/>
+            <a:ext cx="3515258" cy="2043684"/>
           </a:xfrm>
           <a:prstGeom prst="roundRect">
             <a:avLst>
-              <a:gd name="adj" fmla="val 4020"/>
+              <a:gd name="adj" fmla="val 3579"/>
             </a:avLst>
           </a:prstGeom>
           <a:solidFill>
@@ -3600,14 +3600,14 @@
       </p:sp>
       <p:sp>
         <p:nvSpPr>
-          <p:cNvPr id="6" name="D1 Workload subnets protected by segmentation"/>
+          <p:cNvPr id="6" name="D1 Workload subnets with a network security group or firewall route"/>
           <p:cNvSpPr txBox="1"/>
           <p:nvPr/>
         </p:nvSpPr>
         <p:spPr>
           <a:xfrm>
             <a:off x="1371600" y="1783080"/>
-            <a:ext cx="2527706" cy="1527048"/>
+            <a:ext cx="2527706" cy="1751076"/>
           </a:xfrm>
           <a:prstGeom prst="rect">
             <a:avLst/>
@@ -3628,7 +3628,7 @@
                   <a:schemeClr val="tx2"/>
                 </a:solidFill>
               </a:rPr>
-              <a:t>Workload subnets protected by segmentation</a:t>
+              <a:t>Workload subnets with a network security group or firewall route</a:t>
             </a:r>
             <a:endParaRPr lang="en-US" sz="1400" dirty="0"/>
           </a:p>
@@ -3645,7 +3645,7 @@
                   <a:schemeClr val="accent6"/>
                 </a:solidFill>
               </a:rPr>
-              <a:t>Workload subnets with a network security group or a route through the firewall.</a:t>
+              <a:t>Workload subnets with a network security group or a route through the firewall configured. The rules and the traffic they permit are not evaluated.</a:t>
             </a:r>
             <a:endParaRPr lang="en-US" sz="1400" dirty="0"/>
           </a:p>
@@ -3660,11 +3660,11 @@
         <p:spPr>
           <a:xfrm>
             <a:off x="4338218" y="1600200"/>
-            <a:ext cx="3515258" cy="1819656"/>
+            <a:ext cx="3515258" cy="2043684"/>
           </a:xfrm>
           <a:prstGeom prst="roundRect">
             <a:avLst>
-              <a:gd name="adj" fmla="val 4020"/>
+              <a:gd name="adj" fmla="val 3579"/>
             </a:avLst>
           </a:prstGeom>
           <a:solidFill>
@@ -3727,7 +3727,7 @@
         <p:spPr>
           <a:xfrm>
             <a:off x="5161178" y="1783080"/>
-            <a:ext cx="2527706" cy="1527048"/>
+            <a:ext cx="2527706" cy="1751076"/>
           </a:xfrm>
           <a:prstGeom prst="rect">
             <a:avLst/>
@@ -3780,11 +3780,11 @@
         <p:spPr>
           <a:xfrm>
             <a:off x="8127797" y="1600200"/>
-            <a:ext cx="3515258" cy="1819656"/>
+            <a:ext cx="3515258" cy="2043684"/>
           </a:xfrm>
           <a:prstGeom prst="roundRect">
             <a:avLst>
-              <a:gd name="adj" fmla="val 4020"/>
+              <a:gd name="adj" fmla="val 3579"/>
             </a:avLst>
           </a:prstGeom>
           <a:solidFill>
@@ -3847,7 +3847,7 @@
         <p:spPr>
           <a:xfrm>
             <a:off x="8950757" y="1783080"/>
-            <a:ext cx="2527706" cy="1527048"/>
+            <a:ext cx="2527706" cy="1751076"/>
           </a:xfrm>
           <a:prstGeom prst="rect">
             <a:avLst/>
@@ -3899,12 +3899,12 @@
         </p:nvSpPr>
         <p:spPr>
           <a:xfrm>
-            <a:off x="548640" y="3694176"/>
-            <a:ext cx="3515258" cy="1819656"/>
+            <a:off x="548640" y="3918204"/>
+            <a:ext cx="3515258" cy="2043684"/>
           </a:xfrm>
           <a:prstGeom prst="roundRect">
             <a:avLst>
-              <a:gd name="adj" fmla="val 4020"/>
+              <a:gd name="adj" fmla="val 3579"/>
             </a:avLst>
           </a:prstGeom>
           <a:solidFill>
@@ -3926,7 +3926,7 @@
         </p:nvSpPr>
         <p:spPr>
           <a:xfrm>
-            <a:off x="731520" y="3895344"/>
+            <a:off x="731520" y="4119372"/>
             <a:ext cx="502920" cy="329184"/>
           </a:xfrm>
           <a:prstGeom prst="roundRect">
@@ -3966,8 +3966,8 @@
         </p:nvSpPr>
         <p:spPr>
           <a:xfrm>
-            <a:off x="1371600" y="3877056"/>
-            <a:ext cx="2527706" cy="1527048"/>
+            <a:off x="1371600" y="4101084"/>
+            <a:ext cx="2527706" cy="1751076"/>
           </a:xfrm>
           <a:prstGeom prst="rect">
             <a:avLst/>
@@ -4019,12 +4019,12 @@
         </p:nvSpPr>
         <p:spPr>
           <a:xfrm>
-            <a:off x="4338218" y="3694176"/>
-            <a:ext cx="3515258" cy="1819656"/>
+            <a:off x="4338218" y="3918204"/>
+            <a:ext cx="3515258" cy="2043684"/>
           </a:xfrm>
           <a:prstGeom prst="roundRect">
             <a:avLst>
-              <a:gd name="adj" fmla="val 4020"/>
+              <a:gd name="adj" fmla="val 3579"/>
             </a:avLst>
           </a:prstGeom>
           <a:solidFill>
@@ -4046,7 +4046,7 @@
         </p:nvSpPr>
         <p:spPr>
           <a:xfrm>
-            <a:off x="4521098" y="3895344"/>
+            <a:off x="4521098" y="4119372"/>
             <a:ext cx="502920" cy="329184"/>
           </a:xfrm>
           <a:prstGeom prst="roundRect">
@@ -4086,8 +4086,8 @@
         </p:nvSpPr>
         <p:spPr>
           <a:xfrm>
-            <a:off x="5161178" y="3877056"/>
-            <a:ext cx="2527706" cy="1527048"/>
+            <a:off x="5161178" y="4101084"/>
+            <a:ext cx="2527706" cy="1751076"/>
           </a:xfrm>
           <a:prstGeom prst="rect">
             <a:avLst/>
@@ -4826,7 +4826,7 @@
                   <a:schemeClr val="accent6"/>
                 </a:solidFill>
               </a:rPr>
-              <a:t>Managed disks encrypted with platform or customer managed keys.</a:t>
+              <a:t>Managed disks encrypted with platform or customer managed keys. Platform-managed encryption is on by default in Azure, so this reads the default. Encryption at host is graded separately.</a:t>
             </a:r>
             <a:endParaRPr lang="en-US" sz="1400" dirty="0"/>
           </a:p>
@@ -4901,7 +4901,7 @@
       </p:sp>
       <p:sp>
         <p:nvSpPr>
-          <p:cNvPr id="21" name="F6 Safe Links scanning on mail, Teams and Office"/>
+          <p:cNvPr id="21" name="F6 Safe Links policy configured for mail, Teams and Office"/>
           <p:cNvSpPr txBox="1"/>
           <p:nvPr/>
         </p:nvSpPr>
@@ -4929,7 +4929,7 @@
                   <a:schemeClr val="tx2"/>
                 </a:solidFill>
               </a:rPr>
-              <a:t>Safe Links scanning on mail, Teams and Office</a:t>
+              <a:t>Safe Links policy configured for mail, Teams and Office</a:t>
             </a:r>
             <a:endParaRPr lang="en-US" sz="1400" dirty="0"/>
           </a:p>
@@ -4946,7 +4946,7 @@
                   <a:schemeClr val="accent6"/>
                 </a:solidFill>
               </a:rPr>
-              <a:t>At least one Safe Links policy covers mail, Teams and Office.</a:t>
+              <a:t>At least one Safe Links policy has Safe Links on for mail, Teams and Office. The recipients it applies to, its exceptions and its rule state are not read.</a:t>
             </a:r>
             <a:endParaRPr lang="en-US" sz="1400" dirty="0"/>
           </a:p>
@@ -5021,7 +5021,7 @@
       </p:sp>
       <p:sp>
         <p:nvSpPr>
-          <p:cNvPr id="24" name="F7 Safe Attachments blocking malicious files"/>
+          <p:cNvPr id="24" name="F7 Safe Attachments policy set to block or replace malicious files"/>
           <p:cNvSpPr txBox="1"/>
           <p:nvPr/>
         </p:nvSpPr>
@@ -5049,7 +5049,7 @@
                   <a:schemeClr val="tx2"/>
                 </a:solidFill>
               </a:rPr>
-              <a:t>Safe Attachments blocking malicious files</a:t>
+              <a:t>Safe Attachments policy set to block or replace malicious files</a:t>
             </a:r>
             <a:endParaRPr lang="en-US" sz="1400" dirty="0"/>
           </a:p>
@@ -5066,7 +5066,7 @@
                   <a:schemeClr val="accent6"/>
                 </a:solidFill>
               </a:rPr>
-              <a:t>At least one enabled Safe Attachments policy blocks or replaces malicious attachments.</a:t>
+              <a:t>At least one enabled Safe Attachments policy is set to block or replace malicious attachments. The recipients it applies to and its exceptions are not read.</a:t>
             </a:r>
             <a:endParaRPr lang="en-US" sz="1400" dirty="0"/>
           </a:p>
@@ -6183,7 +6183,7 @@
       </p:sp>
       <p:sp>
         <p:nvSpPr>
-          <p:cNvPr id="9" name="F2 Cloud workload protection across the resource estate"/>
+          <p:cNvPr id="9" name="F2 Cloud workload protection plan coverage, a plan-level estimate"/>
           <p:cNvSpPr txBox="1"/>
           <p:nvPr/>
         </p:nvSpPr>
@@ -6211,7 +6211,7 @@
                   <a:schemeClr val="tx2"/>
                 </a:solidFill>
               </a:rPr>
-              <a:t>Cloud workload protection across the resource estate</a:t>
+              <a:t>Cloud workload protection plan coverage, a plan-level estimate</a:t>
             </a:r>
             <a:endParaRPr lang="en-US" sz="1400" dirty="0"/>
           </a:p>
@@ -6228,7 +6228,7 @@
                   <a:schemeClr val="accent6"/>
                 </a:solidFill>
               </a:rPr>
-              <a:t>Eligible resources on a Standard Defender for Cloud plan, read from the subscription plan configuration.</a:t>
+              <a:t>Eligible resources on a Standard Defender for Cloud plan, a plan-level estimate read from the subscription plan configuration.</a:t>
             </a:r>
             <a:endParaRPr lang="en-US" sz="1400" dirty="0"/>
           </a:p>

</xml_diff>

<commit_message>
Shorten the email and disk notes so the standard cards hold them
The controls-standard deck caps each card at 1.69 in on the 9-card Data
protection slide. The longer DP.3, Safe Links and Safe Attachments notes
needed up to 2.24 in and ran past their cards. The notes now say the same
in fewer words, the Safe Links label reads "policy set" so it wraps to
two lines, and a deck test holds the five configuration-presence cards
to the builder's own estimate. The standard is regenerated.

Co-Authored-By: Claude Opus 5.5 <noreply@anthropic.com>
Claude-Session: https://claude.ai/code/session_01G7sqHHZgrkqDvVG64pLwvx
</commit_message>
<xml_diff>
--- a/docs/The Controls That Matter.pptx
+++ b/docs/The Controls That Matter.pptx
@@ -121,7 +121,7 @@
   <p:extLst>
     <p:ext uri="{521415D9-36F7-43E2-AB2F-B90AF26B5E84}">
       <p14:sectionLst xmlns:p14="http://schemas.microsoft.com/office/powerpoint/2010/main">
-        <p14:section name="Overview" id="{31478f99-389b-eb79-72af-7347030f6c2e}">
+        <p14:section name="Overview" id="{f6b6b2b6-acd0-56dd-a06b-c85865f17d88}">
           <p14:sldIdLst>
             <p14:sldId id="256"/>
             <p14:sldId id="257"/>
@@ -129,37 +129,37 @@
             <p14:sldId id="259"/>
           </p14:sldIdLst>
         </p14:section>
-        <p14:section name="Identity and access" id="{359860de-30f9-99a3-eb67-4a2585a45746}">
+        <p14:section name="Identity and access" id="{93c79d61-57ef-e15f-8e44-29a4e05a537f}">
           <p14:sldIdLst>
             <p14:sldId id="260"/>
             <p14:sldId id="261"/>
           </p14:sldIdLst>
         </p14:section>
-        <p14:section name="Endpoint and workload" id="{bc59fcf3-2dcd-42b3-afdc-24ab344257a2}">
+        <p14:section name="Endpoint and workload" id="{6c5be07a-13ac-76c2-8e7b-d6f5d436e7cc}">
           <p14:sldIdLst>
             <p14:sldId id="262"/>
             <p14:sldId id="263"/>
           </p14:sldIdLst>
         </p14:section>
-        <p14:section name="Network and boundary" id="{7db857fc-a341-eb07-2b28-d7e8edadbabc}">
+        <p14:section name="Network and boundary" id="{1dfa328d-b8b8-7115-e6c9-39381a56a772}">
           <p14:sldIdLst>
             <p14:sldId id="264"/>
             <p14:sldId id="265"/>
           </p14:sldIdLst>
         </p14:section>
-        <p14:section name="Data protection" id="{8d75dd8e-404f-1b5d-bfc3-17b1ee3bceff}">
+        <p14:section name="Data protection" id="{d11244b8-a45a-ecca-e027-ebb96017c4f6}">
           <p14:sldIdLst>
             <p14:sldId id="266"/>
             <p14:sldId id="267"/>
           </p14:sldIdLst>
         </p14:section>
-        <p14:section name="Detection and response" id="{0a3fcf14-c01c-13b1-c1e5-a53c60077814}">
+        <p14:section name="Detection and response" id="{b2d7f890-8dbd-7d85-ffd5-2fbcbfc8e0d0}">
           <p14:sldIdLst>
             <p14:sldId id="268"/>
             <p14:sldId id="269"/>
           </p14:sldIdLst>
         </p14:section>
-        <p14:section name="Feedback" id="{1e5eb518-a4bd-02c0-ee3e-57e242cd3c0d}">
+        <p14:section name="Feedback" id="{52972e77-1143-b1d3-47a5-487c258f6192}">
           <p14:sldIdLst>
             <p14:sldId id="270"/>
           </p14:sldIdLst>
@@ -1101,7 +1101,7 @@
           <a:p>
             <a:r>
               <a:rPr lang="en-US" dirty="0"/>
-              <a:t>Data protection, foundational controls. These are configured when the environment is built and are expected at E at every review. Secure transfer required on storage accounts: Storage accounts configured to require secure transfer. Storage minimum TLS 1.2: Storage accounts requiring TLS 1.2 or newer. Key Vault soft delete: Vaults able to recover deleted secrets, keys and certificates. Key Vault purge protection: Vaults protected against permanent deletion during the retention period. Managed disks encrypted at rest: Managed disks encrypted with platform or customer managed keys. Platform-managed encryption is on by default in Azure, so this reads the default. Encryption at host is graded separately. Safe Links policy configured for mail, Teams and Office: At least one Safe Links policy has Safe Links on for mail, Teams and Office. The recipients it applies to, its exceptions and its rule state are not read. Safe Attachments policy set to block or replace malicious files: At least one enabled Safe Attachments policy is set to block or replace malicious attachments. The recipients it applies to and its exceptions are not read. Malicious mail removed after delivery: Post-delivery removals of malicious mail in the last 30 days. Zero-hour auto purge enabled for malware, spam and phishing: Every malware and content filter policy keeps zero-hour auto purge on.</a:t>
+              <a:t>Data protection, foundational controls. These are configured when the environment is built and are expected at E at every review. Secure transfer required on storage accounts: Storage accounts configured to require secure transfer. Storage minimum TLS 1.2: Storage accounts requiring TLS 1.2 or newer. Key Vault soft delete: Vaults able to recover deleted secrets, keys and certificates. Key Vault purge protection: Vaults protected against permanent deletion during the retention period. Managed disks encrypted at rest: Platform keys, the Azure default, or customer managed keys. Encryption at host is graded separately. Safe Links policy set for mail, Teams and Office: One policy with all three on is enough. Recipients, exceptions and rule state are not read. Safe Attachments policy set to block or replace malicious files: One enabled policy is enough. Scope and exceptions are not read. Malicious mail removed after delivery: Post-delivery removals of malicious mail in the last 30 days. Zero-hour auto purge enabled for malware, spam and phishing: Every malware and content filter policy keeps zero-hour auto purge on.</a:t>
             </a:r>
             <a:endParaRPr lang="en-US" dirty="0"/>
           </a:p>
@@ -4826,7 +4826,7 @@
                   <a:schemeClr val="accent6"/>
                 </a:solidFill>
               </a:rPr>
-              <a:t>Managed disks encrypted with platform or customer managed keys. Platform-managed encryption is on by default in Azure, so this reads the default. Encryption at host is graded separately.</a:t>
+              <a:t>Platform keys, the Azure default, or customer managed keys. Encryption at host is graded separately.</a:t>
             </a:r>
             <a:endParaRPr lang="en-US" sz="1400" dirty="0"/>
           </a:p>
@@ -4901,7 +4901,7 @@
       </p:sp>
       <p:sp>
         <p:nvSpPr>
-          <p:cNvPr id="21" name="F6 Safe Links policy configured for mail, Teams and Office"/>
+          <p:cNvPr id="21" name="F6 Safe Links policy set for mail, Teams and Office"/>
           <p:cNvSpPr txBox="1"/>
           <p:nvPr/>
         </p:nvSpPr>
@@ -4929,7 +4929,7 @@
                   <a:schemeClr val="tx2"/>
                 </a:solidFill>
               </a:rPr>
-              <a:t>Safe Links policy configured for mail, Teams and Office</a:t>
+              <a:t>Safe Links policy set for mail, Teams and Office</a:t>
             </a:r>
             <a:endParaRPr lang="en-US" sz="1400" dirty="0"/>
           </a:p>
@@ -4946,7 +4946,7 @@
                   <a:schemeClr val="accent6"/>
                 </a:solidFill>
               </a:rPr>
-              <a:t>At least one Safe Links policy has Safe Links on for mail, Teams and Office. The recipients it applies to, its exceptions and its rule state are not read.</a:t>
+              <a:t>One policy with all three on is enough. Recipients, exceptions and rule state are not read.</a:t>
             </a:r>
             <a:endParaRPr lang="en-US" sz="1400" dirty="0"/>
           </a:p>
@@ -5066,7 +5066,7 @@
                   <a:schemeClr val="accent6"/>
                 </a:solidFill>
               </a:rPr>
-              <a:t>At least one enabled Safe Attachments policy is set to block or replace malicious attachments. The recipients it applies to and its exceptions are not read.</a:t>
+              <a:t>One enabled policy is enough. Scope and exceptions are not read.</a:t>
             </a:r>
             <a:endParaRPr lang="en-US" sz="1400" dirty="0"/>
           </a:p>

</xml_diff>

<commit_message>
Word the email notes as how they are read, not as sufficiency
"One policy ... is enough" could read as a protection claim in a client
register. The Safe Links note now says it reads In force when one policy
has all three on, and the Safe Attachments note says it is read from any
one enabled policy. Both still fit their standard cards.

Co-Authored-By: Claude Opus 5.5 <noreply@anthropic.com>
Claude-Session: https://claude.ai/code/session_01G7sqHHZgrkqDvVG64pLwvx
</commit_message>
<xml_diff>
--- a/docs/The Controls That Matter.pptx
+++ b/docs/The Controls That Matter.pptx
@@ -121,7 +121,7 @@
   <p:extLst>
     <p:ext uri="{521415D9-36F7-43E2-AB2F-B90AF26B5E84}">
       <p14:sectionLst xmlns:p14="http://schemas.microsoft.com/office/powerpoint/2010/main">
-        <p14:section name="Overview" id="{f6b6b2b6-acd0-56dd-a06b-c85865f17d88}">
+        <p14:section name="Overview" id="{287254b8-9147-04bb-0464-98982e9e9b7b}">
           <p14:sldIdLst>
             <p14:sldId id="256"/>
             <p14:sldId id="257"/>
@@ -129,37 +129,37 @@
             <p14:sldId id="259"/>
           </p14:sldIdLst>
         </p14:section>
-        <p14:section name="Identity and access" id="{93c79d61-57ef-e15f-8e44-29a4e05a537f}">
+        <p14:section name="Identity and access" id="{17122bc1-c6e4-1f8f-f1fa-4aee8567ec30}">
           <p14:sldIdLst>
             <p14:sldId id="260"/>
             <p14:sldId id="261"/>
           </p14:sldIdLst>
         </p14:section>
-        <p14:section name="Endpoint and workload" id="{6c5be07a-13ac-76c2-8e7b-d6f5d436e7cc}">
+        <p14:section name="Endpoint and workload" id="{4e69d21d-f4ae-51a1-0890-e6d3371e9c65}">
           <p14:sldIdLst>
             <p14:sldId id="262"/>
             <p14:sldId id="263"/>
           </p14:sldIdLst>
         </p14:section>
-        <p14:section name="Network and boundary" id="{1dfa328d-b8b8-7115-e6c9-39381a56a772}">
+        <p14:section name="Network and boundary" id="{5d673e84-21ef-54ed-8cf8-d98095fa6c5a}">
           <p14:sldIdLst>
             <p14:sldId id="264"/>
             <p14:sldId id="265"/>
           </p14:sldIdLst>
         </p14:section>
-        <p14:section name="Data protection" id="{d11244b8-a45a-ecca-e027-ebb96017c4f6}">
+        <p14:section name="Data protection" id="{4ea8832e-839d-658c-869c-7a7542426cc8}">
           <p14:sldIdLst>
             <p14:sldId id="266"/>
             <p14:sldId id="267"/>
           </p14:sldIdLst>
         </p14:section>
-        <p14:section name="Detection and response" id="{b2d7f890-8dbd-7d85-ffd5-2fbcbfc8e0d0}">
+        <p14:section name="Detection and response" id="{3972d8b1-72d0-5081-2f85-2ea678bc0419}">
           <p14:sldIdLst>
             <p14:sldId id="268"/>
             <p14:sldId id="269"/>
           </p14:sldIdLst>
         </p14:section>
-        <p14:section name="Feedback" id="{52972e77-1143-b1d3-47a5-487c258f6192}">
+        <p14:section name="Feedback" id="{f338314b-1177-d08f-2523-befb31eea2ab}">
           <p14:sldIdLst>
             <p14:sldId id="270"/>
           </p14:sldIdLst>
@@ -1101,7 +1101,7 @@
           <a:p>
             <a:r>
               <a:rPr lang="en-US" dirty="0"/>
-              <a:t>Data protection, foundational controls. These are configured when the environment is built and are expected at E at every review. Secure transfer required on storage accounts: Storage accounts configured to require secure transfer. Storage minimum TLS 1.2: Storage accounts requiring TLS 1.2 or newer. Key Vault soft delete: Vaults able to recover deleted secrets, keys and certificates. Key Vault purge protection: Vaults protected against permanent deletion during the retention period. Managed disks encrypted at rest: Platform keys, the Azure default, or customer managed keys. Encryption at host is graded separately. Safe Links policy set for mail, Teams and Office: One policy with all three on is enough. Recipients, exceptions and rule state are not read. Safe Attachments policy set to block or replace malicious files: One enabled policy is enough. Scope and exceptions are not read. Malicious mail removed after delivery: Post-delivery removals of malicious mail in the last 30 days. Zero-hour auto purge enabled for malware, spam and phishing: Every malware and content filter policy keeps zero-hour auto purge on.</a:t>
+              <a:t>Data protection, foundational controls. These are configured when the environment is built and are expected at E at every review. Secure transfer required on storage accounts: Storage accounts configured to require secure transfer. Storage minimum TLS 1.2: Storage accounts requiring TLS 1.2 or newer. Key Vault soft delete: Vaults able to recover deleted secrets, keys and certificates. Key Vault purge protection: Vaults protected against permanent deletion during the retention period. Managed disks encrypted at rest: Platform keys, the Azure default, or customer managed keys. Encryption at host is graded separately. Safe Links policy set for mail, Teams and Office: Reads In force when one policy has all three on. Recipients, exceptions and rule state are not read. Safe Attachments policy set to block or replace malicious files: Read from any one enabled policy. Scope and exceptions are not read. Malicious mail removed after delivery: Post-delivery removals of malicious mail in the last 30 days. Zero-hour auto purge enabled for malware, spam and phishing: Every malware and content filter policy keeps zero-hour auto purge on.</a:t>
             </a:r>
             <a:endParaRPr lang="en-US" dirty="0"/>
           </a:p>
@@ -4946,7 +4946,7 @@
                   <a:schemeClr val="accent6"/>
                 </a:solidFill>
               </a:rPr>
-              <a:t>One policy with all three on is enough. Recipients, exceptions and rule state are not read.</a:t>
+              <a:t>Reads In force when one policy has all three on. Recipients, exceptions and rule state are not read.</a:t>
             </a:r>
             <a:endParaRPr lang="en-US" sz="1400" dirty="0"/>
           </a:p>
@@ -5066,7 +5066,7 @@
                   <a:schemeClr val="accent6"/>
                 </a:solidFill>
               </a:rPr>
-              <a:t>One enabled policy is enough. Scope and exceptions are not read.</a:t>
+              <a:t>Read from any one enabled policy. Scope and exceptions are not read.</a:t>
             </a:r>
             <a:endParaRPr lang="en-US" sz="1400" dirty="0"/>
           </a:p>

</xml_diff>